<commit_message>
Update project files and prepare for GitHub migration
</commit_message>
<xml_diff>
--- a/DocuMind_Presentation.pptx
+++ b/DocuMind_Presentation.pptx
@@ -17,6 +17,9 @@
     <p:sldId id="265" r:id="rId16"/>
     <p:sldId id="266" r:id="rId17"/>
     <p:sldId id="267" r:id="rId18"/>
+    <p:sldId id="268" r:id="rId19"/>
+    <p:sldId id="269" r:id="rId20"/>
+    <p:sldId id="270" r:id="rId21"/>
   </p:sldIdLst>
   <p:sldSz cx="9144000" cy="6858000" type="screen4x3"/>
   <p:notesSz cx="6858000" cy="9144000"/>
@@ -3092,14 +3095,6 @@
 <file path=ppt/slides/slide1.xml><?xml version="1.0" encoding="utf-8"?>
 <p:sld xmlns:a="http://schemas.openxmlformats.org/drawingml/2006/main" xmlns:p="http://schemas.openxmlformats.org/presentationml/2006/main" xmlns:r="http://schemas.openxmlformats.org/officeDocument/2006/relationships">
   <p:cSld>
-    <p:bg>
-      <p:bgPr>
-        <a:solidFill>
-          <a:srgbClr val="0F172A"/>
-        </a:solidFill>
-        <a:effectLst/>
-      </p:bgPr>
-    </p:bg>
     <p:spTree>
       <p:nvGrpSpPr>
         <p:cNvPr id="1" name=""/>
@@ -3125,7 +3120,7 @@
             <a:pPr>
               <a:defRPr b="1">
                 <a:solidFill>
-                  <a:srgbClr val="3B82F6"/>
+                  <a:srgbClr val="4F46E5"/>
                 </a:solidFill>
               </a:defRPr>
             </a:pPr>
@@ -3153,18 +3148,23 @@
             <a:pPr>
               <a:defRPr>
                 <a:solidFill>
-                  <a:srgbClr val="FFFFFF"/>
+                  <a:srgbClr val="1E293B"/>
                 </a:solidFill>
               </a:defRPr>
             </a:pPr>
             <a:r>
-              <a:t>Your Private Enterprise AI Knowledge Base</a:t>
+              <a:t>AI-Powered Document Intelligence Platform using RAG Architecture</a:t>
             </a:r>
           </a:p>
           <a:p/>
           <a:p>
             <a:r>
-              <a:t>Grounded Intelligence. Zero Hallucination. Total Security.</a:t>
+              <a:t>Nilofar Sayyad (MCA II)</a:t>
+            </a:r>
+          </a:p>
+          <a:p>
+            <a:r>
+              <a:t>Pirens IBMA, Loni</a:t>
             </a:r>
           </a:p>
         </p:txBody>
@@ -3180,14 +3180,6 @@
 <file path=ppt/slides/slide10.xml><?xml version="1.0" encoding="utf-8"?>
 <p:sld xmlns:a="http://schemas.openxmlformats.org/drawingml/2006/main" xmlns:p="http://schemas.openxmlformats.org/presentationml/2006/main" xmlns:r="http://schemas.openxmlformats.org/officeDocument/2006/relationships">
   <p:cSld>
-    <p:bg>
-      <p:bgPr>
-        <a:solidFill>
-          <a:srgbClr val="0F172A"/>
-        </a:solidFill>
-        <a:effectLst/>
-      </p:bgPr>
-    </p:bg>
     <p:spTree>
       <p:nvGrpSpPr>
         <p:cNvPr id="1" name=""/>
@@ -3211,14 +3203,14 @@
           <a:lstStyle/>
           <a:p>
             <a:pPr>
-              <a:defRPr b="1">
+              <a:defRPr>
                 <a:solidFill>
-                  <a:srgbClr val="3B82F6"/>
+                  <a:srgbClr val="4F46E5"/>
                 </a:solidFill>
               </a:defRPr>
             </a:pPr>
             <a:r>
-              <a:t>The Tech Stack</a:t>
+              <a:t>User Management Module</a:t>
             </a:r>
           </a:p>
         </p:txBody>
@@ -3240,62 +3232,66 @@
           <a:p/>
           <a:p>
             <a:pPr>
-              <a:spcAft>
-                <a:spcPts val="1000"/>
-              </a:spcAft>
-              <a:defRPr sz="1800">
-                <a:solidFill>
-                  <a:srgbClr val="E2E8F0"/>
-                </a:solidFill>
-              </a:defRPr>
-            </a:pPr>
-            <a:r>
-              <a:t>Backend: Python, SQLAlchemy, Celery, Pydantic.</a:t>
-            </a:r>
-          </a:p>
-          <a:p>
-            <a:pPr>
-              <a:spcAft>
-                <a:spcPts val="1000"/>
-              </a:spcAft>
-              <a:defRPr sz="1800">
-                <a:solidFill>
-                  <a:srgbClr val="E2E8F0"/>
-                </a:solidFill>
-              </a:defRPr>
-            </a:pPr>
-            <a:r>
-              <a:t>Database: PostgreSQL, Redis.</a:t>
-            </a:r>
-          </a:p>
-          <a:p>
-            <a:pPr>
-              <a:spcAft>
-                <a:spcPts val="1000"/>
-              </a:spcAft>
-              <a:defRPr sz="1800">
-                <a:solidFill>
-                  <a:srgbClr val="E2E8F0"/>
-                </a:solidFill>
-              </a:defRPr>
-            </a:pPr>
-            <a:r>
-              <a:t>Inference: Groq (Llama 3.1 70B/8B).</a:t>
-            </a:r>
-          </a:p>
-          <a:p>
-            <a:pPr>
-              <a:spcAft>
-                <a:spcPts val="1000"/>
-              </a:spcAft>
-              <a:defRPr sz="1800">
-                <a:solidFill>
-                  <a:srgbClr val="E2E8F0"/>
-                </a:solidFill>
-              </a:defRPr>
-            </a:pPr>
-            <a:r>
-              <a:t>Frontend: React, Tailwind, Framer Motion, Zustand.</a:t>
+              <a:defRPr b="1" sz="2000"/>
+            </a:pPr>
+            <a:r>
+              <a:t>Secure Authentication</a:t>
+            </a:r>
+          </a:p>
+          <a:p>
+            <a:pPr lvl="1">
+              <a:defRPr sz="1600"/>
+            </a:pPr>
+            <a:r>
+              <a:t>JWT-based sessions with password hashing (BCrypt).</a:t>
+            </a:r>
+          </a:p>
+          <a:p>
+            <a:pPr>
+              <a:defRPr b="1" sz="2000"/>
+            </a:pPr>
+            <a:r>
+              <a:t>Ownership Isolation</a:t>
+            </a:r>
+          </a:p>
+          <a:p>
+            <a:pPr lvl="1">
+              <a:defRPr sz="1600"/>
+            </a:pPr>
+            <a:r>
+              <a:t>Secure multi-tenancy where users only access their own data.</a:t>
+            </a:r>
+          </a:p>
+          <a:p>
+            <a:pPr>
+              <a:defRPr b="1" sz="2000"/>
+            </a:pPr>
+            <a:r>
+              <a:t>Member Profiles</a:t>
+            </a:r>
+          </a:p>
+          <a:p>
+            <a:pPr lvl="1">
+              <a:defRPr sz="1600"/>
+            </a:pPr>
+            <a:r>
+              <a:t>Personalized settings, theme management, and account dashboard.</a:t>
+            </a:r>
+          </a:p>
+          <a:p>
+            <a:pPr>
+              <a:defRPr b="1" sz="2000"/>
+            </a:pPr>
+            <a:r>
+              <a:t>Role-Based Flow</a:t>
+            </a:r>
+          </a:p>
+          <a:p>
+            <a:pPr lvl="1">
+              <a:defRPr sz="1600"/>
+            </a:pPr>
+            <a:r>
+              <a:t>Structured interactions for different user tiers (Member/Admin).</a:t>
             </a:r>
           </a:p>
         </p:txBody>
@@ -3311,14 +3307,6 @@
 <file path=ppt/slides/slide11.xml><?xml version="1.0" encoding="utf-8"?>
 <p:sld xmlns:a="http://schemas.openxmlformats.org/drawingml/2006/main" xmlns:p="http://schemas.openxmlformats.org/presentationml/2006/main" xmlns:r="http://schemas.openxmlformats.org/officeDocument/2006/relationships">
   <p:cSld>
-    <p:bg>
-      <p:bgPr>
-        <a:solidFill>
-          <a:srgbClr val="0F172A"/>
-        </a:solidFill>
-        <a:effectLst/>
-      </p:bgPr>
-    </p:bg>
     <p:spTree>
       <p:nvGrpSpPr>
         <p:cNvPr id="1" name=""/>
@@ -3342,14 +3330,14 @@
           <a:lstStyle/>
           <a:p>
             <a:pPr>
-              <a:defRPr b="1">
+              <a:defRPr>
                 <a:solidFill>
-                  <a:srgbClr val="3B82F6"/>
+                  <a:srgbClr val="4F46E5"/>
                 </a:solidFill>
               </a:defRPr>
             </a:pPr>
             <a:r>
-              <a:t>Enterprise Roadmap</a:t>
+              <a:t>Project Walkthrough</a:t>
             </a:r>
           </a:p>
         </p:txBody>
@@ -3366,71 +3354,59 @@
         </p:nvSpPr>
         <p:spPr/>
         <p:txBody>
-          <a:bodyPr wrap="square"/>
+          <a:bodyPr/>
           <a:lstStyle/>
           <a:p/>
-          <a:p>
-            <a:pPr>
-              <a:spcAft>
-                <a:spcPts val="1000"/>
-              </a:spcAft>
-              <a:defRPr sz="1800">
-                <a:solidFill>
-                  <a:srgbClr val="E2E8F0"/>
-                </a:solidFill>
-              </a:defRPr>
-            </a:pPr>
-            <a:r>
-              <a:t>RBAC: Granular department-level access controls.</a:t>
-            </a:r>
-          </a:p>
-          <a:p>
-            <a:pPr>
-              <a:spcAft>
-                <a:spcPts val="1000"/>
-              </a:spcAft>
-              <a:defRPr sz="1800">
-                <a:solidFill>
-                  <a:srgbClr val="E2E8F0"/>
-                </a:solidFill>
-              </a:defRPr>
-            </a:pPr>
-            <a:r>
-              <a:t>Cloud Sync: Auto-indexing from SharePoint/Google Drive.</a:t>
-            </a:r>
-          </a:p>
-          <a:p>
-            <a:pPr>
-              <a:spcAft>
-                <a:spcPts val="1000"/>
-              </a:spcAft>
-              <a:defRPr sz="1800">
-                <a:solidFill>
-                  <a:srgbClr val="E2E8F0"/>
-                </a:solidFill>
-              </a:defRPr>
-            </a:pPr>
-            <a:r>
-              <a:t>Integrations: Slack and Microsoft Teams native bot support.</a:t>
-            </a:r>
-          </a:p>
-          <a:p>
-            <a:pPr>
-              <a:spcAft>
-                <a:spcPts val="1000"/>
-              </a:spcAft>
-              <a:defRPr sz="1800">
-                <a:solidFill>
-                  <a:srgbClr val="E2E8F0"/>
-                </a:solidFill>
-              </a:defRPr>
-            </a:pPr>
-            <a:r>
-              <a:t>Advanced Citations: PDF viewer with inline highlighting.</a:t>
-            </a:r>
-          </a:p>
-        </p:txBody>
-      </p:sp>
+        </p:txBody>
+      </p:sp>
+      <p:pic>
+        <p:nvPicPr>
+          <p:cNvPr id="4" name="Picture 3" descr="dashboard.png"/>
+          <p:cNvPicPr>
+            <a:picLocks noChangeAspect="1"/>
+          </p:cNvPicPr>
+          <p:nvPr/>
+        </p:nvPicPr>
+        <p:blipFill>
+          <a:blip r:embed="rId2"/>
+          <a:stretch>
+            <a:fillRect/>
+          </a:stretch>
+        </p:blipFill>
+        <p:spPr>
+          <a:xfrm>
+            <a:off x="457200" y="1828800"/>
+            <a:ext cx="3840480" cy="2403814"/>
+          </a:xfrm>
+          <a:prstGeom prst="rect">
+            <a:avLst/>
+          </a:prstGeom>
+        </p:spPr>
+      </p:pic>
+      <p:pic>
+        <p:nvPicPr>
+          <p:cNvPr id="5" name="Picture 4" descr="chat.png"/>
+          <p:cNvPicPr>
+            <a:picLocks noChangeAspect="1"/>
+          </p:cNvPicPr>
+          <p:nvPr/>
+        </p:nvPicPr>
+        <p:blipFill>
+          <a:blip r:embed="rId3"/>
+          <a:stretch>
+            <a:fillRect/>
+          </a:stretch>
+        </p:blipFill>
+        <p:spPr>
+          <a:xfrm>
+            <a:off x="4754880" y="1828800"/>
+            <a:ext cx="3840480" cy="1706568"/>
+          </a:xfrm>
+          <a:prstGeom prst="rect">
+            <a:avLst/>
+          </a:prstGeom>
+        </p:spPr>
+      </p:pic>
     </p:spTree>
   </p:cSld>
   <p:clrMapOvr>
@@ -3442,14 +3418,6 @@
 <file path=ppt/slides/slide12.xml><?xml version="1.0" encoding="utf-8"?>
 <p:sld xmlns:a="http://schemas.openxmlformats.org/drawingml/2006/main" xmlns:p="http://schemas.openxmlformats.org/presentationml/2006/main" xmlns:r="http://schemas.openxmlformats.org/officeDocument/2006/relationships">
   <p:cSld>
-    <p:bg>
-      <p:bgPr>
-        <a:solidFill>
-          <a:srgbClr val="0F172A"/>
-        </a:solidFill>
-        <a:effectLst/>
-      </p:bgPr>
-    </p:bg>
     <p:spTree>
       <p:nvGrpSpPr>
         <p:cNvPr id="1" name=""/>
@@ -3473,91 +3441,418 @@
           <a:lstStyle/>
           <a:p>
             <a:pPr>
+              <a:defRPr>
+                <a:solidFill>
+                  <a:srgbClr val="4F46E5"/>
+                </a:solidFill>
+              </a:defRPr>
+            </a:pPr>
+            <a:r>
+              <a:t>Future Roadmap</a:t>
+            </a:r>
+          </a:p>
+        </p:txBody>
+      </p:sp>
+      <p:sp>
+        <p:nvSpPr>
+          <p:cNvPr id="3" name="Content Placeholder 2"/>
+          <p:cNvSpPr>
+            <a:spLocks noGrp="1"/>
+          </p:cNvSpPr>
+          <p:nvPr>
+            <p:ph idx="1"/>
+          </p:nvPr>
+        </p:nvSpPr>
+        <p:spPr/>
+        <p:txBody>
+          <a:bodyPr wrap="square"/>
+          <a:lstStyle/>
+          <a:p/>
+          <a:p>
+            <a:pPr>
+              <a:defRPr b="1" sz="2000"/>
+            </a:pPr>
+            <a:r>
+              <a:t>Phase 1: Core RAG</a:t>
+            </a:r>
+          </a:p>
+          <a:p>
+            <a:pPr lvl="1">
+              <a:defRPr sz="1600"/>
+            </a:pPr>
+            <a:r>
+              <a:t>Database integration and async pipeline (Completed).</a:t>
+            </a:r>
+          </a:p>
+          <a:p>
+            <a:pPr>
+              <a:defRPr b="1" sz="2000"/>
+            </a:pPr>
+            <a:r>
+              <a:t>Phase 2: Advanced Intelligence</a:t>
+            </a:r>
+          </a:p>
+          <a:p>
+            <a:pPr lvl="1">
+              <a:defRPr sz="1600"/>
+            </a:pPr>
+            <a:r>
+              <a:t>Multi-modal OCR support and vision-based interpretation.</a:t>
+            </a:r>
+          </a:p>
+          <a:p>
+            <a:pPr>
+              <a:defRPr b="1" sz="2000"/>
+            </a:pPr>
+            <a:r>
+              <a:t>Phase 3: Enterprise Auth</a:t>
+            </a:r>
+          </a:p>
+          <a:p>
+            <a:pPr lvl="1">
+              <a:defRPr sz="1600"/>
+            </a:pPr>
+            <a:r>
+              <a:t>Fine-grained ACL and role-based access control.</a:t>
+            </a:r>
+          </a:p>
+          <a:p>
+            <a:pPr>
+              <a:defRPr b="1" sz="2000"/>
+            </a:pPr>
+            <a:r>
+              <a:t>Phase 4: Collaboration</a:t>
+            </a:r>
+          </a:p>
+          <a:p>
+            <a:pPr lvl="1">
+              <a:defRPr sz="1600"/>
+            </a:pPr>
+            <a:r>
+              <a:t>Shared vector spaces and organization-level document pools.</a:t>
+            </a:r>
+          </a:p>
+        </p:txBody>
+      </p:sp>
+    </p:spTree>
+  </p:cSld>
+  <p:clrMapOvr>
+    <a:masterClrMapping/>
+  </p:clrMapOvr>
+</p:sld>
+</file>
+
+<file path=ppt/slides/slide13.xml><?xml version="1.0" encoding="utf-8"?>
+<p:sld xmlns:a="http://schemas.openxmlformats.org/drawingml/2006/main" xmlns:p="http://schemas.openxmlformats.org/presentationml/2006/main" xmlns:r="http://schemas.openxmlformats.org/officeDocument/2006/relationships">
+  <p:cSld>
+    <p:spTree>
+      <p:nvGrpSpPr>
+        <p:cNvPr id="1" name=""/>
+        <p:cNvGrpSpPr/>
+        <p:nvPr/>
+      </p:nvGrpSpPr>
+      <p:grpSpPr/>
+      <p:sp>
+        <p:nvSpPr>
+          <p:cNvPr id="2" name="Title 1"/>
+          <p:cNvSpPr>
+            <a:spLocks noGrp="1"/>
+          </p:cNvSpPr>
+          <p:nvPr>
+            <p:ph type="title"/>
+          </p:nvPr>
+        </p:nvSpPr>
+        <p:spPr/>
+        <p:txBody>
+          <a:bodyPr/>
+          <a:lstStyle/>
+          <a:p>
+            <a:pPr>
+              <a:defRPr>
+                <a:solidFill>
+                  <a:srgbClr val="4F46E5"/>
+                </a:solidFill>
+              </a:defRPr>
+            </a:pPr>
+            <a:r>
+              <a:t>Roadmap: Technical Implementation</a:t>
+            </a:r>
+          </a:p>
+        </p:txBody>
+      </p:sp>
+      <p:sp>
+        <p:nvSpPr>
+          <p:cNvPr id="3" name="Content Placeholder 2"/>
+          <p:cNvSpPr>
+            <a:spLocks noGrp="1"/>
+          </p:cNvSpPr>
+          <p:nvPr>
+            <p:ph idx="1"/>
+          </p:nvPr>
+        </p:nvSpPr>
+        <p:spPr/>
+        <p:txBody>
+          <a:bodyPr wrap="square"/>
+          <a:lstStyle/>
+          <a:p/>
+          <a:p>
+            <a:pPr>
+              <a:defRPr b="1" sz="2000"/>
+            </a:pPr>
+            <a:r>
+              <a:t>🖼️ Multi-modal OCR</a:t>
+            </a:r>
+          </a:p>
+          <a:p>
+            <a:pPr lvl="1">
+              <a:defRPr sz="1600"/>
+            </a:pPr>
+            <a:r>
+              <a:t>Using Tesseract/EasyOCR for scanning and Llama 3.2 Vision for diagrams.</a:t>
+            </a:r>
+          </a:p>
+          <a:p>
+            <a:pPr>
+              <a:defRPr b="1" sz="2000"/>
+            </a:pPr>
+            <a:r>
+              <a:t>🔐 Advanced Auth</a:t>
+            </a:r>
+          </a:p>
+          <a:p>
+            <a:pPr lvl="1">
+              <a:defRPr sz="1600"/>
+            </a:pPr>
+            <a:r>
+              <a:t>Expanding our JWT foundation to include OAuth2 and Multi-Factor Auth (MFA).</a:t>
+            </a:r>
+          </a:p>
+          <a:p>
+            <a:pPr>
+              <a:defRPr b="1" sz="2000"/>
+            </a:pPr>
+            <a:r>
+              <a:t>👥 Team Collaboration</a:t>
+            </a:r>
+          </a:p>
+          <a:p>
+            <a:pPr lvl="1">
+              <a:defRPr sz="1600"/>
+            </a:pPr>
+            <a:r>
+              <a:t>Implementing Organisation-level Document Pools and Shared Vector Indexes.</a:t>
+            </a:r>
+          </a:p>
+          <a:p>
+            <a:pPr>
+              <a:defRPr b="1" sz="2000"/>
+            </a:pPr>
+            <a:r>
+              <a:t>🚀 Scalability</a:t>
+            </a:r>
+          </a:p>
+          <a:p>
+            <a:pPr lvl="1">
+              <a:defRPr sz="1600"/>
+            </a:pPr>
+            <a:r>
+              <a:t>Shifting to dedicated vector engines like Pinecone for billion-scale document handling.</a:t>
+            </a:r>
+          </a:p>
+        </p:txBody>
+      </p:sp>
+    </p:spTree>
+  </p:cSld>
+  <p:clrMapOvr>
+    <a:masterClrMapping/>
+  </p:clrMapOvr>
+</p:sld>
+</file>
+
+<file path=ppt/slides/slide14.xml><?xml version="1.0" encoding="utf-8"?>
+<p:sld xmlns:a="http://schemas.openxmlformats.org/drawingml/2006/main" xmlns:p="http://schemas.openxmlformats.org/presentationml/2006/main" xmlns:r="http://schemas.openxmlformats.org/officeDocument/2006/relationships">
+  <p:cSld>
+    <p:spTree>
+      <p:nvGrpSpPr>
+        <p:cNvPr id="1" name=""/>
+        <p:cNvGrpSpPr/>
+        <p:nvPr/>
+      </p:nvGrpSpPr>
+      <p:grpSpPr/>
+      <p:sp>
+        <p:nvSpPr>
+          <p:cNvPr id="2" name="Title 1"/>
+          <p:cNvSpPr>
+            <a:spLocks noGrp="1"/>
+          </p:cNvSpPr>
+          <p:nvPr>
+            <p:ph type="title"/>
+          </p:nvPr>
+        </p:nvSpPr>
+        <p:spPr/>
+        <p:txBody>
+          <a:bodyPr/>
+          <a:lstStyle/>
+          <a:p>
+            <a:pPr>
+              <a:defRPr>
+                <a:solidFill>
+                  <a:srgbClr val="4F46E5"/>
+                </a:solidFill>
+              </a:defRPr>
+            </a:pPr>
+            <a:r>
+              <a:t>Conclusion &amp; Impact</a:t>
+            </a:r>
+          </a:p>
+        </p:txBody>
+      </p:sp>
+      <p:sp>
+        <p:nvSpPr>
+          <p:cNvPr id="3" name="Content Placeholder 2"/>
+          <p:cNvSpPr>
+            <a:spLocks noGrp="1"/>
+          </p:cNvSpPr>
+          <p:nvPr>
+            <p:ph idx="1"/>
+          </p:nvPr>
+        </p:nvSpPr>
+        <p:spPr/>
+        <p:txBody>
+          <a:bodyPr wrap="square"/>
+          <a:lstStyle/>
+          <a:p/>
+          <a:p>
+            <a:pPr>
+              <a:defRPr b="1" sz="2000"/>
+            </a:pPr>
+            <a:r>
+              <a:t>Technical Achievement</a:t>
+            </a:r>
+          </a:p>
+          <a:p>
+            <a:pPr lvl="1">
+              <a:defRPr sz="1600"/>
+            </a:pPr>
+            <a:r>
+              <a:t>Distributed RAG pipeline with sub-second retrieval and generation.</a:t>
+            </a:r>
+          </a:p>
+          <a:p>
+            <a:pPr>
+              <a:defRPr b="1" sz="2000"/>
+            </a:pPr>
+            <a:r>
+              <a:t>Practical Utility</a:t>
+            </a:r>
+          </a:p>
+          <a:p>
+            <a:pPr lvl="1">
+              <a:defRPr sz="1600"/>
+            </a:pPr>
+            <a:r>
+              <a:t>Reduces document research time by up to 90%.</a:t>
+            </a:r>
+          </a:p>
+          <a:p>
+            <a:pPr>
+              <a:defRPr b="1" sz="2000"/>
+            </a:pPr>
+            <a:r>
+              <a:t>Platform Stability</a:t>
+            </a:r>
+          </a:p>
+          <a:p>
+            <a:pPr lvl="1">
+              <a:defRPr sz="1600"/>
+            </a:pPr>
+            <a:r>
+              <a:t>Scalable containerized architecture ready for production.</a:t>
+            </a:r>
+          </a:p>
+        </p:txBody>
+      </p:sp>
+    </p:spTree>
+  </p:cSld>
+  <p:clrMapOvr>
+    <a:masterClrMapping/>
+  </p:clrMapOvr>
+</p:sld>
+</file>
+
+<file path=ppt/slides/slide15.xml><?xml version="1.0" encoding="utf-8"?>
+<p:sld xmlns:a="http://schemas.openxmlformats.org/drawingml/2006/main" xmlns:p="http://schemas.openxmlformats.org/presentationml/2006/main" xmlns:r="http://schemas.openxmlformats.org/officeDocument/2006/relationships">
+  <p:cSld>
+    <p:spTree>
+      <p:nvGrpSpPr>
+        <p:cNvPr id="1" name=""/>
+        <p:cNvGrpSpPr/>
+        <p:nvPr/>
+      </p:nvGrpSpPr>
+      <p:grpSpPr/>
+      <p:sp>
+        <p:nvSpPr>
+          <p:cNvPr id="2" name="Title 1"/>
+          <p:cNvSpPr>
+            <a:spLocks noGrp="1"/>
+          </p:cNvSpPr>
+          <p:nvPr>
+            <p:ph type="ctrTitle"/>
+          </p:nvPr>
+        </p:nvSpPr>
+        <p:spPr/>
+        <p:txBody>
+          <a:bodyPr/>
+          <a:lstStyle/>
+          <a:p>
+            <a:pPr>
               <a:defRPr b="1">
                 <a:solidFill>
-                  <a:srgbClr val="3B82F6"/>
+                  <a:srgbClr val="4F46E5"/>
                 </a:solidFill>
               </a:defRPr>
             </a:pPr>
             <a:r>
-              <a:t>Thank You</a:t>
-            </a:r>
-          </a:p>
-        </p:txBody>
-      </p:sp>
-      <p:sp>
-        <p:nvSpPr>
-          <p:cNvPr id="3" name="Content Placeholder 2"/>
-          <p:cNvSpPr>
-            <a:spLocks noGrp="1"/>
-          </p:cNvSpPr>
-          <p:nvPr>
-            <p:ph idx="1"/>
-          </p:nvPr>
-        </p:nvSpPr>
-        <p:spPr/>
-        <p:txBody>
-          <a:bodyPr wrap="square"/>
-          <a:lstStyle/>
-          <a:p/>
-          <a:p>
-            <a:pPr>
-              <a:spcAft>
-                <a:spcPts val="1000"/>
-              </a:spcAft>
-              <a:defRPr sz="1800">
+              <a:t>Thank You!</a:t>
+            </a:r>
+          </a:p>
+        </p:txBody>
+      </p:sp>
+      <p:sp>
+        <p:nvSpPr>
+          <p:cNvPr id="3" name="Subtitle 2"/>
+          <p:cNvSpPr>
+            <a:spLocks noGrp="1"/>
+          </p:cNvSpPr>
+          <p:nvPr>
+            <p:ph type="subTitle" idx="1"/>
+          </p:nvPr>
+        </p:nvSpPr>
+        <p:spPr/>
+        <p:txBody>
+          <a:bodyPr/>
+          <a:lstStyle/>
+          <a:p>
+            <a:pPr>
+              <a:defRPr>
                 <a:solidFill>
-                  <a:srgbClr val="E2E8F0"/>
+                  <a:srgbClr val="1E293B"/>
                 </a:solidFill>
               </a:defRPr>
             </a:pPr>
             <a:r>
-              <a:t>Questions?</a:t>
-            </a:r>
-          </a:p>
-          <a:p>
-            <a:pPr>
-              <a:spcAft>
-                <a:spcPts val="1000"/>
-              </a:spcAft>
-              <a:defRPr sz="1800">
-                <a:solidFill>
-                  <a:srgbClr val="E2E8F0"/>
-                </a:solidFill>
-              </a:defRPr>
-            </a:pPr>
-            <a:r>
-              <a:t>Website: documind.ai</a:t>
-            </a:r>
-          </a:p>
-          <a:p>
-            <a:pPr>
-              <a:spcAft>
-                <a:spcPts val="1000"/>
-              </a:spcAft>
-              <a:defRPr sz="1800">
-                <a:solidFill>
-                  <a:srgbClr val="E2E8F0"/>
-                </a:solidFill>
-              </a:defRPr>
-            </a:pPr>
-            <a:r>
-              <a:t>Email: contact@documind.ai</a:t>
-            </a:r>
-          </a:p>
-          <a:p>
-            <a:pPr>
-              <a:spcAft>
-                <a:spcPts val="1000"/>
-              </a:spcAft>
-              <a:defRPr sz="1800">
-                <a:solidFill>
-                  <a:srgbClr val="E2E8F0"/>
-                </a:solidFill>
-              </a:defRPr>
-            </a:pPr>
-            <a:r>
-              <a:t>Transforming Data into Intelligence.</a:t>
+              <a:t>Any Questions?</a:t>
+            </a:r>
+          </a:p>
+          <a:p/>
+          <a:p>
+            <a:r>
+              <a:t>DocuMind Project 2026</a:t>
+            </a:r>
+          </a:p>
+          <a:p>
+            <a:r>
+              <a:t>Presented to Science &amp; Tech Seminar</a:t>
             </a:r>
           </a:p>
         </p:txBody>
@@ -3573,14 +3868,6 @@
 <file path=ppt/slides/slide2.xml><?xml version="1.0" encoding="utf-8"?>
 <p:sld xmlns:a="http://schemas.openxmlformats.org/drawingml/2006/main" xmlns:p="http://schemas.openxmlformats.org/presentationml/2006/main" xmlns:r="http://schemas.openxmlformats.org/officeDocument/2006/relationships">
   <p:cSld>
-    <p:bg>
-      <p:bgPr>
-        <a:solidFill>
-          <a:srgbClr val="0F172A"/>
-        </a:solidFill>
-        <a:effectLst/>
-      </p:bgPr>
-    </p:bg>
     <p:spTree>
       <p:nvGrpSpPr>
         <p:cNvPr id="1" name=""/>
@@ -3604,14 +3891,14 @@
           <a:lstStyle/>
           <a:p>
             <a:pPr>
-              <a:defRPr b="1">
+              <a:defRPr>
                 <a:solidFill>
-                  <a:srgbClr val="3B82F6"/>
+                  <a:srgbClr val="4F46E5"/>
                 </a:solidFill>
               </a:defRPr>
             </a:pPr>
             <a:r>
-              <a:t>The Problem: 'The Data Graveyard'</a:t>
+              <a:t>The Challenge</a:t>
             </a:r>
           </a:p>
         </p:txBody>
@@ -3633,62 +3920,50 @@
           <a:p/>
           <a:p>
             <a:pPr>
-              <a:spcAft>
-                <a:spcPts val="1000"/>
-              </a:spcAft>
-              <a:defRPr sz="1800">
-                <a:solidFill>
-                  <a:srgbClr val="E2E8F0"/>
-                </a:solidFill>
-              </a:defRPr>
-            </a:pPr>
-            <a:r>
-              <a:t>Information Overload: Critical knowledge buried in isolated PDFs/Code files.</a:t>
-            </a:r>
-          </a:p>
-          <a:p>
-            <a:pPr>
-              <a:spcAft>
-                <a:spcPts val="1000"/>
-              </a:spcAft>
-              <a:defRPr sz="1800">
-                <a:solidFill>
-                  <a:srgbClr val="E2E8F0"/>
-                </a:solidFill>
-              </a:defRPr>
-            </a:pPr>
-            <a:r>
-              <a:t>Operational Inefficiency: Employees waste ~20% of their day searching.</a:t>
-            </a:r>
-          </a:p>
-          <a:p>
-            <a:pPr>
-              <a:spcAft>
-                <a:spcPts val="1000"/>
-              </a:spcAft>
-              <a:defRPr sz="1800">
-                <a:solidFill>
-                  <a:srgbClr val="E2E8F0"/>
-                </a:solidFill>
-              </a:defRPr>
-            </a:pPr>
-            <a:r>
-              <a:t>AI Hallucination: Public AI lacks specific contextual grounding.</a:t>
-            </a:r>
-          </a:p>
-          <a:p>
-            <a:pPr>
-              <a:spcAft>
-                <a:spcPts val="1000"/>
-              </a:spcAft>
-              <a:defRPr sz="1800">
-                <a:solidFill>
-                  <a:srgbClr val="E2E8F0"/>
-                </a:solidFill>
-              </a:defRPr>
-            </a:pPr>
-            <a:r>
-              <a:t>Privacy Risks: Sensitive data exposure to public models.</a:t>
+              <a:defRPr b="1" sz="2000"/>
+            </a:pPr>
+            <a:r>
+              <a:t>Information Overload</a:t>
+            </a:r>
+          </a:p>
+          <a:p>
+            <a:pPr lvl="1">
+              <a:defRPr sz="1600"/>
+            </a:pPr>
+            <a:r>
+              <a:t>Managing thousands of documents manually is impossible and prone to error.</a:t>
+            </a:r>
+          </a:p>
+          <a:p>
+            <a:pPr>
+              <a:defRPr b="1" sz="2000"/>
+            </a:pPr>
+            <a:r>
+              <a:t>Slow Retrieval</a:t>
+            </a:r>
+          </a:p>
+          <a:p>
+            <a:pPr lvl="1">
+              <a:defRPr sz="1600"/>
+            </a:pPr>
+            <a:r>
+              <a:t>Finding specific information in deeply nested PDFs takes hours of manual searching.</a:t>
+            </a:r>
+          </a:p>
+          <a:p>
+            <a:pPr>
+              <a:defRPr b="1" sz="2000"/>
+            </a:pPr>
+            <a:r>
+              <a:t>Context Blindness</a:t>
+            </a:r>
+          </a:p>
+          <a:p>
+            <a:pPr lvl="1">
+              <a:defRPr sz="1600"/>
+            </a:pPr>
+            <a:r>
+              <a:t>Traditional search fails to understand the actual meaning and context of queries.</a:t>
             </a:r>
           </a:p>
         </p:txBody>
@@ -3704,14 +3979,6 @@
 <file path=ppt/slides/slide3.xml><?xml version="1.0" encoding="utf-8"?>
 <p:sld xmlns:a="http://schemas.openxmlformats.org/drawingml/2006/main" xmlns:p="http://schemas.openxmlformats.org/presentationml/2006/main" xmlns:r="http://schemas.openxmlformats.org/officeDocument/2006/relationships">
   <p:cSld>
-    <p:bg>
-      <p:bgPr>
-        <a:solidFill>
-          <a:srgbClr val="0F172A"/>
-        </a:solidFill>
-        <a:effectLst/>
-      </p:bgPr>
-    </p:bg>
     <p:spTree>
       <p:nvGrpSpPr>
         <p:cNvPr id="1" name=""/>
@@ -3735,14 +4002,14 @@
           <a:lstStyle/>
           <a:p>
             <a:pPr>
-              <a:defRPr b="1">
+              <a:defRPr>
                 <a:solidFill>
-                  <a:srgbClr val="3B82F6"/>
+                  <a:srgbClr val="4F46E5"/>
                 </a:solidFill>
               </a:defRPr>
             </a:pPr>
             <a:r>
-              <a:t>The Solution: RAG-Powered Intel</a:t>
+              <a:t>The Solution: DocuMind</a:t>
             </a:r>
           </a:p>
         </p:txBody>
@@ -3764,62 +4031,74 @@
           <a:p/>
           <a:p>
             <a:pPr>
-              <a:spcAft>
-                <a:spcPts val="1000"/>
-              </a:spcAft>
-              <a:defRPr sz="1800">
-                <a:solidFill>
-                  <a:srgbClr val="E2E8F0"/>
-                </a:solidFill>
-              </a:defRPr>
-            </a:pPr>
-            <a:r>
-              <a:t>Connect: Seamlessly upload PDFs, DOCX, and Source Code.</a:t>
-            </a:r>
-          </a:p>
-          <a:p>
-            <a:pPr>
-              <a:spcAft>
-                <a:spcPts val="1000"/>
-              </a:spcAft>
-              <a:defRPr sz="1800">
-                <a:solidFill>
-                  <a:srgbClr val="E2E8F0"/>
-                </a:solidFill>
-              </a:defRPr>
-            </a:pPr>
-            <a:r>
-              <a:t>Understand: Semantic awareness through high-dimensional vector search.</a:t>
-            </a:r>
-          </a:p>
-          <a:p>
-            <a:pPr>
-              <a:spcAft>
-                <a:spcPts val="1000"/>
-              </a:spcAft>
-              <a:defRPr sz="1800">
-                <a:solidFill>
-                  <a:srgbClr val="E2E8F0"/>
-                </a:solidFill>
-              </a:defRPr>
-            </a:pPr>
-            <a:r>
-              <a:t>Chat: Natural language interaction with your own private data.</a:t>
-            </a:r>
-          </a:p>
-          <a:p>
-            <a:pPr>
-              <a:spcAft>
-                <a:spcPts val="1000"/>
-              </a:spcAft>
-              <a:defRPr sz="1800">
-                <a:solidFill>
-                  <a:srgbClr val="E2E8F0"/>
-                </a:solidFill>
-              </a:defRPr>
-            </a:pPr>
-            <a:r>
-              <a:t>Verify: Source citations for every AI response ensure 100% accuracy.</a:t>
+              <a:defRPr sz="1800"/>
+            </a:pPr>
+            <a:r>
+              <a:t>Leveraging Retrieval-Augmented Generation (RAG) to bridge the gap between static documents and AI.</a:t>
+            </a:r>
+          </a:p>
+          <a:p>
+            <a:pPr>
+              <a:defRPr b="1" sz="2000"/>
+            </a:pPr>
+            <a:r>
+              <a:t>Step 1: Ingestion</a:t>
+            </a:r>
+          </a:p>
+          <a:p>
+            <a:pPr lvl="1">
+              <a:defRPr sz="1600"/>
+            </a:pPr>
+            <a:r>
+              <a:t>Smart processing of PDFs and text files.</a:t>
+            </a:r>
+          </a:p>
+          <a:p>
+            <a:pPr>
+              <a:defRPr b="1" sz="2000"/>
+            </a:pPr>
+            <a:r>
+              <a:t>Step 2: Vectorization</a:t>
+            </a:r>
+          </a:p>
+          <a:p>
+            <a:pPr lvl="1">
+              <a:defRPr sz="1600"/>
+            </a:pPr>
+            <a:r>
+              <a:t>Encoding content into mathematical representations.</a:t>
+            </a:r>
+          </a:p>
+          <a:p>
+            <a:pPr>
+              <a:defRPr b="1" sz="2000"/>
+            </a:pPr>
+            <a:r>
+              <a:t>Step 3: Retrieval</a:t>
+            </a:r>
+          </a:p>
+          <a:p>
+            <a:pPr lvl="1">
+              <a:defRPr sz="1600"/>
+            </a:pPr>
+            <a:r>
+              <a:t>Context-aware search using pgvector.</a:t>
+            </a:r>
+          </a:p>
+          <a:p>
+            <a:pPr>
+              <a:defRPr b="1" sz="2000"/>
+            </a:pPr>
+            <a:r>
+              <a:t>Step 4: Generation</a:t>
+            </a:r>
+          </a:p>
+          <a:p>
+            <a:pPr lvl="1">
+              <a:defRPr sz="1600"/>
+            </a:pPr>
+            <a:r>
+              <a:t>Ultra-fast response generation via Groq Llama 3.</a:t>
             </a:r>
           </a:p>
         </p:txBody>
@@ -3835,14 +4114,6 @@
 <file path=ppt/slides/slide4.xml><?xml version="1.0" encoding="utf-8"?>
 <p:sld xmlns:a="http://schemas.openxmlformats.org/drawingml/2006/main" xmlns:p="http://schemas.openxmlformats.org/presentationml/2006/main" xmlns:r="http://schemas.openxmlformats.org/officeDocument/2006/relationships">
   <p:cSld>
-    <p:bg>
-      <p:bgPr>
-        <a:solidFill>
-          <a:srgbClr val="0F172A"/>
-        </a:solidFill>
-        <a:effectLst/>
-      </p:bgPr>
-    </p:bg>
     <p:spTree>
       <p:nvGrpSpPr>
         <p:cNvPr id="1" name=""/>
@@ -3866,14 +4137,14 @@
           <a:lstStyle/>
           <a:p>
             <a:pPr>
-              <a:defRPr b="1">
+              <a:defRPr>
                 <a:solidFill>
-                  <a:srgbClr val="3B82F6"/>
+                  <a:srgbClr val="4F46E5"/>
                 </a:solidFill>
               </a:defRPr>
             </a:pPr>
             <a:r>
-              <a:t>High-Level Architecture</a:t>
+              <a:t>RAG 101: Core Concepts</a:t>
             </a:r>
           </a:p>
         </p:txBody>
@@ -3895,62 +4166,66 @@
           <a:p/>
           <a:p>
             <a:pPr>
-              <a:spcAft>
-                <a:spcPts val="1000"/>
-              </a:spcAft>
-              <a:defRPr sz="1800">
-                <a:solidFill>
-                  <a:srgbClr val="E2E8F0"/>
-                </a:solidFill>
-              </a:defRPr>
-            </a:pPr>
-            <a:r>
-              <a:t>Frontend: React + Vite + Tailwind (Premium Glassmorphism).</a:t>
-            </a:r>
-          </a:p>
-          <a:p>
-            <a:pPr>
-              <a:spcAft>
-                <a:spcPts val="1000"/>
-              </a:spcAft>
-              <a:defRPr sz="1800">
-                <a:solidFill>
-                  <a:srgbClr val="E2E8F0"/>
-                </a:solidFill>
-              </a:defRPr>
-            </a:pPr>
-            <a:r>
-              <a:t>API Layer: FastAPI (High performance, Async).</a:t>
-            </a:r>
-          </a:p>
-          <a:p>
-            <a:pPr>
-              <a:spcAft>
-                <a:spcPts val="1000"/>
-              </a:spcAft>
-              <a:defRPr sz="1800">
-                <a:solidFill>
-                  <a:srgbClr val="E2E8F0"/>
-                </a:solidFill>
-              </a:defRPr>
-            </a:pPr>
-            <a:r>
-              <a:t>Vector Brain: PostgreSQL + pgvector (Semantic Indexing).</a:t>
-            </a:r>
-          </a:p>
-          <a:p>
-            <a:pPr>
-              <a:spcAft>
-                <a:spcPts val="1000"/>
-              </a:spcAft>
-              <a:defRPr sz="1800">
-                <a:solidFill>
-                  <a:srgbClr val="E2E8F0"/>
-                </a:solidFill>
-              </a:defRPr>
-            </a:pPr>
-            <a:r>
-              <a:t>LLM Engine: Groq / Llama 3.1 (Lightning speed inference).</a:t>
+              <a:defRPr b="1" sz="2000"/>
+            </a:pPr>
+            <a:r>
+              <a:t>1. Chunks</a:t>
+            </a:r>
+          </a:p>
+          <a:p>
+            <a:pPr lvl="1">
+              <a:defRPr sz="1600"/>
+            </a:pPr>
+            <a:r>
+              <a:t>Breaking long documents into small, manageable pieces for the AI.</a:t>
+            </a:r>
+          </a:p>
+          <a:p>
+            <a:pPr>
+              <a:defRPr b="1" sz="2000"/>
+            </a:pPr>
+            <a:r>
+              <a:t>2. Embeddings</a:t>
+            </a:r>
+          </a:p>
+          <a:p>
+            <a:pPr lvl="1">
+              <a:defRPr sz="1600"/>
+            </a:pPr>
+            <a:r>
+              <a:t>Converting text into numerical vectors that represent concepts and meaning.</a:t>
+            </a:r>
+          </a:p>
+          <a:p>
+            <a:pPr>
+              <a:defRPr b="1" sz="2000"/>
+            </a:pPr>
+            <a:r>
+              <a:t>3. Retrieval</a:t>
+            </a:r>
+          </a:p>
+          <a:p>
+            <a:pPr lvl="1">
+              <a:defRPr sz="1600"/>
+            </a:pPr>
+            <a:r>
+              <a:t>Finding the exact chunks needed to answer a specific query.</a:t>
+            </a:r>
+          </a:p>
+          <a:p>
+            <a:pPr>
+              <a:defRPr b="1" sz="2000"/>
+            </a:pPr>
+            <a:r>
+              <a:t>4. Augmentation</a:t>
+            </a:r>
+          </a:p>
+          <a:p>
+            <a:pPr lvl="1">
+              <a:defRPr sz="1600"/>
+            </a:pPr>
+            <a:r>
+              <a:t>Giving the AI factual 'Notes' so it doesn't have to hallucinate.</a:t>
             </a:r>
           </a:p>
         </p:txBody>
@@ -3966,14 +4241,6 @@
 <file path=ppt/slides/slide5.xml><?xml version="1.0" encoding="utf-8"?>
 <p:sld xmlns:a="http://schemas.openxmlformats.org/drawingml/2006/main" xmlns:p="http://schemas.openxmlformats.org/presentationml/2006/main" xmlns:r="http://schemas.openxmlformats.org/officeDocument/2006/relationships">
   <p:cSld>
-    <p:bg>
-      <p:bgPr>
-        <a:solidFill>
-          <a:srgbClr val="0F172A"/>
-        </a:solidFill>
-        <a:effectLst/>
-      </p:bgPr>
-    </p:bg>
     <p:spTree>
       <p:nvGrpSpPr>
         <p:cNvPr id="1" name=""/>
@@ -3997,14 +4264,14 @@
           <a:lstStyle/>
           <a:p>
             <a:pPr>
-              <a:defRPr b="1">
+              <a:defRPr>
                 <a:solidFill>
-                  <a:srgbClr val="3B82F6"/>
+                  <a:srgbClr val="4F46E5"/>
                 </a:solidFill>
               </a:defRPr>
             </a:pPr>
             <a:r>
-              <a:t>Phase 1: Smart Ingest</a:t>
+              <a:t>Project Scope</a:t>
             </a:r>
           </a:p>
         </p:txBody>
@@ -4026,62 +4293,50 @@
           <a:p/>
           <a:p>
             <a:pPr>
-              <a:spcAft>
-                <a:spcPts val="1000"/>
-              </a:spcAft>
-              <a:defRPr sz="1800">
-                <a:solidFill>
-                  <a:srgbClr val="E2E8F0"/>
-                </a:solidFill>
-              </a:defRPr>
-            </a:pPr>
-            <a:r>
-              <a:t>Secure Validation: Magic Bytes &amp; SHA256 deduplication.</a:t>
-            </a:r>
-          </a:p>
-          <a:p>
-            <a:pPr>
-              <a:spcAft>
-                <a:spcPts val="1000"/>
-              </a:spcAft>
-              <a:defRPr sz="1800">
-                <a:solidFill>
-                  <a:srgbClr val="E2E8F0"/>
-                </a:solidFill>
-              </a:defRPr>
-            </a:pPr>
-            <a:r>
-              <a:t>Smart Parsing: Specialized AST-based code parsers.</a:t>
-            </a:r>
-          </a:p>
-          <a:p>
-            <a:pPr>
-              <a:spcAft>
-                <a:spcPts val="1000"/>
-              </a:spcAft>
-              <a:defRPr sz="1800">
-                <a:solidFill>
-                  <a:srgbClr val="E2E8F0"/>
-                </a:solidFill>
-              </a:defRPr>
-            </a:pPr>
-            <a:r>
-              <a:t>Scalable Pipeline: Celery workers + Redis background processing.</a:t>
-            </a:r>
-          </a:p>
-          <a:p>
-            <a:pPr>
-              <a:spcAft>
-                <a:spcPts val="1000"/>
-              </a:spcAft>
-              <a:defRPr sz="1800">
-                <a:solidFill>
-                  <a:srgbClr val="E2E8F0"/>
-                </a:solidFill>
-              </a:defRPr>
-            </a:pPr>
-            <a:r>
-              <a:t>Data Integrity: High-accuracy extraction from PDFs and complex Docs.</a:t>
+              <a:defRPr b="1" sz="2000"/>
+            </a:pPr>
+            <a:r>
+              <a:t>Target Audience</a:t>
+            </a:r>
+          </a:p>
+          <a:p>
+            <a:pPr lvl="1">
+              <a:defRPr sz="1600"/>
+            </a:pPr>
+            <a:r>
+              <a:t>Researchers, Academics, Legal Compliance Teams, and Corporate Knowledge Labs.</a:t>
+            </a:r>
+          </a:p>
+          <a:p>
+            <a:pPr>
+              <a:defRPr b="1" sz="2000"/>
+            </a:pPr>
+            <a:r>
+              <a:t>Semantic Intelligence</a:t>
+            </a:r>
+          </a:p>
+          <a:p>
+            <a:pPr lvl="1">
+              <a:defRPr sz="1600"/>
+            </a:pPr>
+            <a:r>
+              <a:t>Moving beyond keyword search to deep conceptual understanding of documents.</a:t>
+            </a:r>
+          </a:p>
+          <a:p>
+            <a:pPr>
+              <a:defRPr b="1" sz="2000"/>
+            </a:pPr>
+            <a:r>
+              <a:t>Scalability</a:t>
+            </a:r>
+          </a:p>
+          <a:p>
+            <a:pPr lvl="1">
+              <a:defRPr sz="1600"/>
+            </a:pPr>
+            <a:r>
+              <a:t>Architected to handle massive PDF libraries with near-instant retrieval speed.</a:t>
             </a:r>
           </a:p>
         </p:txBody>
@@ -4097,14 +4352,6 @@
 <file path=ppt/slides/slide6.xml><?xml version="1.0" encoding="utf-8"?>
 <p:sld xmlns:a="http://schemas.openxmlformats.org/drawingml/2006/main" xmlns:p="http://schemas.openxmlformats.org/presentationml/2006/main" xmlns:r="http://schemas.openxmlformats.org/officeDocument/2006/relationships">
   <p:cSld>
-    <p:bg>
-      <p:bgPr>
-        <a:solidFill>
-          <a:srgbClr val="0F172A"/>
-        </a:solidFill>
-        <a:effectLst/>
-      </p:bgPr>
-    </p:bg>
     <p:spTree>
       <p:nvGrpSpPr>
         <p:cNvPr id="1" name=""/>
@@ -4128,14 +4375,14 @@
           <a:lstStyle/>
           <a:p>
             <a:pPr>
-              <a:defRPr b="1">
+              <a:defRPr>
                 <a:solidFill>
-                  <a:srgbClr val="3B82F6"/>
+                  <a:srgbClr val="4F46E5"/>
                 </a:solidFill>
               </a:defRPr>
             </a:pPr>
             <a:r>
-              <a:t>Phase 2: Vectorization</a:t>
+              <a:t>Real-World Industry Applications</a:t>
             </a:r>
           </a:p>
         </p:txBody>
@@ -4157,62 +4404,66 @@
           <a:p/>
           <a:p>
             <a:pPr>
-              <a:spcAft>
-                <a:spcPts val="1000"/>
-              </a:spcAft>
-              <a:defRPr sz="1800">
-                <a:solidFill>
-                  <a:srgbClr val="E2E8F0"/>
-                </a:solidFill>
-              </a:defRPr>
-            </a:pPr>
-            <a:r>
-              <a:t>Chunking: Recursive character splitting with contextual overlap.</a:t>
-            </a:r>
-          </a:p>
-          <a:p>
-            <a:pPr>
-              <a:spcAft>
-                <a:spcPts val="1000"/>
-              </a:spcAft>
-              <a:defRPr sz="1800">
-                <a:solidFill>
-                  <a:srgbClr val="E2E8F0"/>
-                </a:solidFill>
-              </a:defRPr>
-            </a:pPr>
-            <a:r>
-              <a:t>Embedding: all-MiniLM-L6-v2 (Transformer-based vectors).</a:t>
-            </a:r>
-          </a:p>
-          <a:p>
-            <a:pPr>
-              <a:spcAft>
-                <a:spcPts val="1000"/>
-              </a:spcAft>
-              <a:defRPr sz="1800">
-                <a:solidFill>
-                  <a:srgbClr val="E2E8F0"/>
-                </a:solidFill>
-              </a:defRPr>
-            </a:pPr>
-            <a:r>
-              <a:t>Semantic Storage: Efficient storage of math-based meaning in DB.</a:t>
-            </a:r>
-          </a:p>
-          <a:p>
-            <a:pPr>
-              <a:spcAft>
-                <a:spcPts val="1000"/>
-              </a:spcAft>
-              <a:defRPr sz="1800">
-                <a:solidFill>
-                  <a:srgbClr val="E2E8F0"/>
-                </a:solidFill>
-              </a:defRPr>
-            </a:pPr>
-            <a:r>
-              <a:t>Isolation: User-specific data layers for total tenant security.</a:t>
+              <a:defRPr b="1" sz="2000"/>
+            </a:pPr>
+            <a:r>
+              <a:t>Legal Tech</a:t>
+            </a:r>
+          </a:p>
+          <a:p>
+            <a:pPr lvl="1">
+              <a:defRPr sz="1600"/>
+            </a:pPr>
+            <a:r>
+              <a:t>Automated contract auditing and fast retrieval of legal precedents.</a:t>
+            </a:r>
+          </a:p>
+          <a:p>
+            <a:pPr>
+              <a:defRPr b="1" sz="2000"/>
+            </a:pPr>
+            <a:r>
+              <a:t>Healthcare</a:t>
+            </a:r>
+          </a:p>
+          <a:p>
+            <a:pPr lvl="1">
+              <a:defRPr sz="1600"/>
+            </a:pPr>
+            <a:r>
+              <a:t>Scanning medical journals and patient records for fast diagnosis assistance.</a:t>
+            </a:r>
+          </a:p>
+          <a:p>
+            <a:pPr>
+              <a:defRPr b="1" sz="2000"/>
+            </a:pPr>
+            <a:r>
+              <a:t>Corporate HR</a:t>
+            </a:r>
+          </a:p>
+          <a:p>
+            <a:pPr lvl="1">
+              <a:defRPr sz="1600"/>
+            </a:pPr>
+            <a:r>
+              <a:t>Answering employee policy questions based on company handbooks.</a:t>
+            </a:r>
+          </a:p>
+          <a:p>
+            <a:pPr>
+              <a:defRPr b="1" sz="2000"/>
+            </a:pPr>
+            <a:r>
+              <a:t>Academic Research</a:t>
+            </a:r>
+          </a:p>
+          <a:p>
+            <a:pPr lvl="1">
+              <a:defRPr sz="1600"/>
+            </a:pPr>
+            <a:r>
+              <a:t>Analyzing thousands of research papers for literature reviews.</a:t>
             </a:r>
           </a:p>
         </p:txBody>
@@ -4228,14 +4479,6 @@
 <file path=ppt/slides/slide7.xml><?xml version="1.0" encoding="utf-8"?>
 <p:sld xmlns:a="http://schemas.openxmlformats.org/drawingml/2006/main" xmlns:p="http://schemas.openxmlformats.org/presentationml/2006/main" xmlns:r="http://schemas.openxmlformats.org/officeDocument/2006/relationships">
   <p:cSld>
-    <p:bg>
-      <p:bgPr>
-        <a:solidFill>
-          <a:srgbClr val="0F172A"/>
-        </a:solidFill>
-        <a:effectLst/>
-      </p:bgPr>
-    </p:bg>
     <p:spTree>
       <p:nvGrpSpPr>
         <p:cNvPr id="1" name=""/>
@@ -4259,14 +4502,14 @@
           <a:lstStyle/>
           <a:p>
             <a:pPr>
-              <a:defRPr b="1">
+              <a:defRPr>
                 <a:solidFill>
-                  <a:srgbClr val="3B82F6"/>
+                  <a:srgbClr val="4F46E5"/>
                 </a:solidFill>
               </a:defRPr>
             </a:pPr>
             <a:r>
-              <a:t>Phase 3: The RAG Cycle</a:t>
+              <a:t>System Architecture</a:t>
             </a:r>
           </a:p>
         </p:txBody>
@@ -4288,62 +4531,82 @@
           <a:p/>
           <a:p>
             <a:pPr>
-              <a:spcAft>
-                <a:spcPts val="1000"/>
-              </a:spcAft>
-              <a:defRPr sz="1800">
-                <a:solidFill>
-                  <a:srgbClr val="E2E8F0"/>
-                </a:solidFill>
-              </a:defRPr>
-            </a:pPr>
-            <a:r>
-              <a:t>Query: Turn user natural language into search vectors.</a:t>
-            </a:r>
-          </a:p>
-          <a:p>
-            <a:pPr>
-              <a:spcAft>
-                <a:spcPts val="1000"/>
-              </a:spcAft>
-              <a:defRPr sz="1800">
-                <a:solidFill>
-                  <a:srgbClr val="E2E8F0"/>
-                </a:solidFill>
-              </a:defRPr>
-            </a:pPr>
-            <a:r>
-              <a:t>Retrieve: Instant semantic lookup (1 - Cosine Distance).</a:t>
-            </a:r>
-          </a:p>
-          <a:p>
-            <a:pPr>
-              <a:spcAft>
-                <a:spcPts val="1000"/>
-              </a:spcAft>
-              <a:defRPr sz="1800">
-                <a:solidFill>
-                  <a:srgbClr val="E2E8F0"/>
-                </a:solidFill>
-              </a:defRPr>
-            </a:pPr>
-            <a:r>
-              <a:t>Augment: Real-time context injection into LLM prompt.</a:t>
-            </a:r>
-          </a:p>
-          <a:p>
-            <a:pPr>
-              <a:spcAft>
-                <a:spcPts val="1000"/>
-              </a:spcAft>
-              <a:defRPr sz="1800">
-                <a:solidFill>
-                  <a:srgbClr val="E2E8F0"/>
-                </a:solidFill>
-              </a:defRPr>
-            </a:pPr>
-            <a:r>
-              <a:t>Generate: Verified, context-grounded AI synthesis.</a:t>
+              <a:defRPr b="1" sz="2000"/>
+            </a:pPr>
+            <a:r>
+              <a:t>Frontend Layer</a:t>
+            </a:r>
+          </a:p>
+          <a:p>
+            <a:pPr lvl="1">
+              <a:defRPr sz="1600"/>
+            </a:pPr>
+            <a:r>
+              <a:t>React Client (Vite + Tailwind) for a responsive UI.</a:t>
+            </a:r>
+          </a:p>
+          <a:p>
+            <a:pPr>
+              <a:defRPr b="1" sz="2000"/>
+            </a:pPr>
+            <a:r>
+              <a:t>API Layer</a:t>
+            </a:r>
+          </a:p>
+          <a:p>
+            <a:pPr lvl="1">
+              <a:defRPr sz="1600"/>
+            </a:pPr>
+            <a:r>
+              <a:t>FastAPI Asynchronous Gateway for high-concurrency routing.</a:t>
+            </a:r>
+          </a:p>
+          <a:p>
+            <a:pPr>
+              <a:defRPr b="1" sz="2000"/>
+            </a:pPr>
+            <a:r>
+              <a:t>Logic Layer</a:t>
+            </a:r>
+          </a:p>
+          <a:p>
+            <a:pPr lvl="1">
+              <a:defRPr sz="1600"/>
+            </a:pPr>
+            <a:r>
+              <a:t>Celery &amp; Redis for reliable background task processing.</a:t>
+            </a:r>
+          </a:p>
+          <a:p>
+            <a:pPr>
+              <a:defRPr b="1" sz="2000"/>
+            </a:pPr>
+            <a:r>
+              <a:t>Storage Layer</a:t>
+            </a:r>
+          </a:p>
+          <a:p>
+            <a:pPr lvl="1">
+              <a:defRPr sz="1600"/>
+            </a:pPr>
+            <a:r>
+              <a:t>PostgreSQL 16 + pgvector for high-speed similarity search.</a:t>
+            </a:r>
+          </a:p>
+          <a:p>
+            <a:pPr>
+              <a:defRPr b="1" sz="2000"/>
+            </a:pPr>
+            <a:r>
+              <a:t>AI Layer</a:t>
+            </a:r>
+          </a:p>
+          <a:p>
+            <a:pPr lvl="1">
+              <a:defRPr sz="1600"/>
+            </a:pPr>
+            <a:r>
+              <a:t>Groq LPU hardware for real-time Llama 3 inference.</a:t>
             </a:r>
           </a:p>
         </p:txBody>
@@ -4359,14 +4622,6 @@
 <file path=ppt/slides/slide8.xml><?xml version="1.0" encoding="utf-8"?>
 <p:sld xmlns:a="http://schemas.openxmlformats.org/drawingml/2006/main" xmlns:p="http://schemas.openxmlformats.org/presentationml/2006/main" xmlns:r="http://schemas.openxmlformats.org/officeDocument/2006/relationships">
   <p:cSld>
-    <p:bg>
-      <p:bgPr>
-        <a:solidFill>
-          <a:srgbClr val="0F172A"/>
-        </a:solidFill>
-        <a:effectLst/>
-      </p:bgPr>
-    </p:bg>
     <p:spTree>
       <p:nvGrpSpPr>
         <p:cNvPr id="1" name=""/>
@@ -4390,14 +4645,14 @@
           <a:lstStyle/>
           <a:p>
             <a:pPr>
-              <a:defRPr b="1">
+              <a:defRPr>
                 <a:solidFill>
-                  <a:srgbClr val="3B82F6"/>
+                  <a:srgbClr val="4F46E5"/>
                 </a:solidFill>
               </a:defRPr>
             </a:pPr>
             <a:r>
-              <a:t>Key Use Cases</a:t>
+              <a:t>Technical Stack</a:t>
             </a:r>
           </a:p>
         </p:txBody>
@@ -4419,62 +4674,66 @@
           <a:p/>
           <a:p>
             <a:pPr>
-              <a:spcAft>
-                <a:spcPts val="1000"/>
-              </a:spcAft>
-              <a:defRPr sz="1800">
-                <a:solidFill>
-                  <a:srgbClr val="E2E8F0"/>
-                </a:solidFill>
-              </a:defRPr>
-            </a:pPr>
-            <a:r>
-              <a:t>Academic: Summarize research and clarify lecture notes.</a:t>
-            </a:r>
-          </a:p>
-          <a:p>
-            <a:pPr>
-              <a:spcAft>
-                <a:spcPts val="1000"/>
-              </a:spcAft>
-              <a:defRPr sz="1800">
-                <a:solidFill>
-                  <a:srgbClr val="E2E8F0"/>
-                </a:solidFill>
-              </a:defRPr>
-            </a:pPr>
-            <a:r>
-              <a:t>Legal: Rapidly review multi-document contracts/briefs.</a:t>
-            </a:r>
-          </a:p>
-          <a:p>
-            <a:pPr>
-              <a:spcAft>
-                <a:spcPts val="1000"/>
-              </a:spcAft>
-              <a:defRPr sz="1800">
-                <a:solidFill>
-                  <a:srgbClr val="E2E8F0"/>
-                </a:solidFill>
-              </a:defRPr>
-            </a:pPr>
-            <a:r>
-              <a:t>Dev Teams: Chat with codebases for faster onboarding.</a:t>
-            </a:r>
-          </a:p>
-          <a:p>
-            <a:pPr>
-              <a:spcAft>
-                <a:spcPts val="1000"/>
-              </a:spcAft>
-              <a:defRPr sz="1800">
-                <a:solidFill>
-                  <a:srgbClr val="E2E8F0"/>
-                </a:solidFill>
-              </a:defRPr>
-            </a:pPr>
-            <a:r>
-              <a:t>Corporate: Instant HR/SOP knowledge hub for employees.</a:t>
+              <a:defRPr sz="1800"/>
+            </a:pPr>
+            <a:r>
+              <a:t>• Python 3.12: Core Backend Engine</a:t>
+            </a:r>
+          </a:p>
+          <a:p>
+            <a:pPr>
+              <a:defRPr sz="1800"/>
+            </a:pPr>
+            <a:r>
+              <a:t>• PostgreSQL 16: Robust Database with pgvector extension</a:t>
+            </a:r>
+          </a:p>
+          <a:p>
+            <a:pPr>
+              <a:defRPr sz="1800"/>
+            </a:pPr>
+            <a:r>
+              <a:t>• Docker: Containerized Service Orchestration</a:t>
+            </a:r>
+          </a:p>
+          <a:p>
+            <a:pPr>
+              <a:defRPr sz="1800"/>
+            </a:pPr>
+            <a:r>
+              <a:t>• React.js: Premium Interactive Frontend</a:t>
+            </a:r>
+          </a:p>
+          <a:p>
+            <a:pPr>
+              <a:defRPr sz="1800"/>
+            </a:pPr>
+            <a:r>
+              <a:t>• Groq API: Ultra-fast AI inference engine for source code analysis</a:t>
+            </a:r>
+          </a:p>
+          <a:p>
+            <a:pPr>
+              <a:defRPr sz="1800"/>
+            </a:pPr>
+            <a:r>
+              <a:t>• HuggingFace: MiniLM-L6 embeddings</a:t>
+            </a:r>
+          </a:p>
+          <a:p>
+            <a:pPr>
+              <a:defRPr sz="1800"/>
+            </a:pPr>
+            <a:r>
+              <a:t>• Redis: High-speed Message Broker</a:t>
+            </a:r>
+          </a:p>
+          <a:p>
+            <a:pPr>
+              <a:defRPr sz="1800"/>
+            </a:pPr>
+            <a:r>
+              <a:t>• Prometheus: Real-time System Monitoring</a:t>
             </a:r>
           </a:p>
         </p:txBody>
@@ -4490,14 +4749,6 @@
 <file path=ppt/slides/slide9.xml><?xml version="1.0" encoding="utf-8"?>
 <p:sld xmlns:a="http://schemas.openxmlformats.org/drawingml/2006/main" xmlns:p="http://schemas.openxmlformats.org/presentationml/2006/main" xmlns:r="http://schemas.openxmlformats.org/officeDocument/2006/relationships">
   <p:cSld>
-    <p:bg>
-      <p:bgPr>
-        <a:solidFill>
-          <a:srgbClr val="0F172A"/>
-        </a:solidFill>
-        <a:effectLst/>
-      </p:bgPr>
-    </p:bg>
     <p:spTree>
       <p:nvGrpSpPr>
         <p:cNvPr id="1" name=""/>
@@ -4521,14 +4772,14 @@
           <a:lstStyle/>
           <a:p>
             <a:pPr>
-              <a:defRPr b="1">
+              <a:defRPr>
                 <a:solidFill>
-                  <a:srgbClr val="3B82F6"/>
+                  <a:srgbClr val="4F46E5"/>
                 </a:solidFill>
               </a:defRPr>
             </a:pPr>
             <a:r>
-              <a:t>Advanced Capabilities</a:t>
+              <a:t>Platform Capabilities</a:t>
             </a:r>
           </a:p>
         </p:txBody>
@@ -4550,62 +4801,98 @@
           <a:p/>
           <a:p>
             <a:pPr>
-              <a:spcAft>
-                <a:spcPts val="1000"/>
-              </a:spcAft>
-              <a:defRPr sz="1800">
-                <a:solidFill>
-                  <a:srgbClr val="E2E8F0"/>
-                </a:solidFill>
-              </a:defRPr>
-            </a:pPr>
-            <a:r>
-              <a:t>Multi-Session Chat: Manage multiple persistent histories.</a:t>
-            </a:r>
-          </a:p>
-          <a:p>
-            <a:pPr>
-              <a:spcAft>
-                <a:spcPts val="1000"/>
-              </a:spcAft>
-              <a:defRPr sz="1800">
-                <a:solidFill>
-                  <a:srgbClr val="E2E8F0"/>
-                </a:solidFill>
-              </a:defRPr>
-            </a:pPr>
-            <a:r>
-              <a:t>Multi-Document Synthesis: Find discrepancies across 10+ files.</a:t>
-            </a:r>
-          </a:p>
-          <a:p>
-            <a:pPr>
-              <a:spcAft>
-                <a:spcPts val="1000"/>
-              </a:spcAft>
-              <a:defRPr sz="1800">
-                <a:solidFill>
-                  <a:srgbClr val="E2E8F0"/>
-                </a:solidFill>
-              </a:defRPr>
-            </a:pPr>
-            <a:r>
-              <a:t>Premium UI: Dynamic glassmorphism animations.</a:t>
-            </a:r>
-          </a:p>
-          <a:p>
-            <a:pPr>
-              <a:spcAft>
-                <a:spcPts val="1000"/>
-              </a:spcAft>
-              <a:defRPr sz="1800">
-                <a:solidFill>
-                  <a:srgbClr val="E2E8F0"/>
-                </a:solidFill>
-              </a:defRPr>
-            </a:pPr>
-            <a:r>
-              <a:t>Context Control: Target specific documents for ultra-precision.</a:t>
+              <a:defRPr b="1" sz="2000"/>
+            </a:pPr>
+            <a:r>
+              <a:t>Universal Code Intelligence</a:t>
+            </a:r>
+          </a:p>
+          <a:p>
+            <a:pPr lvl="1">
+              <a:defRPr sz="1600"/>
+            </a:pPr>
+            <a:r>
+              <a:t>Native support for C, C++, Java, Python, JS, &amp; more.</a:t>
+            </a:r>
+          </a:p>
+          <a:p>
+            <a:pPr>
+              <a:defRPr b="1" sz="2000"/>
+            </a:pPr>
+            <a:r>
+              <a:t>Unified Viewer</a:t>
+            </a:r>
+          </a:p>
+          <a:p>
+            <a:pPr lvl="1">
+              <a:defRPr sz="1600"/>
+            </a:pPr>
+            <a:r>
+              <a:t>Preview PDFs, text, and code with live syntax highlighting.</a:t>
+            </a:r>
+          </a:p>
+          <a:p>
+            <a:pPr>
+              <a:defRPr b="1" sz="2000"/>
+            </a:pPr>
+            <a:r>
+              <a:t>Semantic Citations</a:t>
+            </a:r>
+          </a:p>
+          <a:p>
+            <a:pPr lvl="1">
+              <a:defRPr sz="1600"/>
+            </a:pPr>
+            <a:r>
+              <a:t>Every answer is backed by direct quotes and page references.</a:t>
+            </a:r>
+          </a:p>
+          <a:p>
+            <a:pPr>
+              <a:defRPr b="1" sz="2000"/>
+            </a:pPr>
+            <a:r>
+              <a:t>Vectorized Search</a:t>
+            </a:r>
+          </a:p>
+          <a:p>
+            <a:pPr lvl="1">
+              <a:defRPr sz="1600"/>
+            </a:pPr>
+            <a:r>
+              <a:t>Meaning-based retrieval beyond simple keywords.</a:t>
+            </a:r>
+          </a:p>
+          <a:p>
+            <a:pPr>
+              <a:defRPr b="1" sz="2000"/>
+            </a:pPr>
+            <a:r>
+              <a:t>Async OCR</a:t>
+            </a:r>
+          </a:p>
+          <a:p>
+            <a:pPr lvl="1">
+              <a:defRPr sz="1600"/>
+            </a:pPr>
+            <a:r>
+              <a:t>Handles batches of complex documents in the background.</a:t>
+            </a:r>
+          </a:p>
+          <a:p>
+            <a:pPr>
+              <a:defRPr b="1" sz="2000"/>
+            </a:pPr>
+            <a:r>
+              <a:t>Modern Security</a:t>
+            </a:r>
+          </a:p>
+          <a:p>
+            <a:pPr lvl="1">
+              <a:defRPr sz="1600"/>
+            </a:pPr>
+            <a:r>
+              <a:t>Built-in rate limiting and protected API endpoints.</a:t>
             </a:r>
           </a:p>
         </p:txBody>

</xml_diff>